<commit_message>
Appendix A: every row states its provenance - the star was a novelty claim, not an authorship mark
The manager and factory carried no label and so read as not-ours, when both
are written from scratch (the manager's virtue being 7710 compatibility, the
factory's the EIP-712 owner binding). Three columns now: name, provenance,
address - and the footnote states the axis: six of eight are our code, the
star means 'a condition no deployed framework has', and the two vendored
audits running unmodified are themselves the compatibility proof.
</commit_message>
<xml_diff>
--- a/docs/pitch/mapae_pitch_v3.pptx
+++ b/docs/pitch/mapae_pitch_v3.pptx
@@ -9076,7 +9076,7 @@
         <p:spPr>
           <a:xfrm>
             <a:off x="822960" y="1828800"/>
-            <a:ext cx="5486400" cy="411480"/>
+            <a:ext cx="3200400" cy="411480"/>
           </a:xfrm>
           <a:prstGeom prst="rect">
             <a:avLst/>
@@ -9114,24 +9114,63 @@
         </p:nvSpPr>
         <p:spPr>
           <a:xfrm>
-            <a:off x="6400800" y="1856232"/>
-            <a:ext cx="4937760" cy="365760"/>
-          </a:xfrm>
-          <a:prstGeom prst="rect">
-            <a:avLst/>
-          </a:prstGeom>
-          <a:noFill/>
-          <a:ln/>
-        </p:spPr>
-        <p:txBody>
-          <a:bodyPr wrap="square" lIns="0" tIns="0" rIns="0" bIns="0" rtlCol="0" anchor="ctr"/>
-          <a:lstStyle/>
-          <a:p>
-            <a:pPr indent="0" marL="0">
-              <a:buNone/>
-            </a:pPr>
-            <a:r>
-              <a:rPr lang="en-US" sz="1100" dirty="0">
+            <a:off x="3977640" y="1856232"/>
+            <a:ext cx="2880360" cy="365760"/>
+          </a:xfrm>
+          <a:prstGeom prst="rect">
+            <a:avLst/>
+          </a:prstGeom>
+          <a:noFill/>
+          <a:ln/>
+        </p:spPr>
+        <p:txBody>
+          <a:bodyPr wrap="square" lIns="0" tIns="0" rIns="0" bIns="0" rtlCol="0" anchor="ctr"/>
+          <a:lstStyle/>
+          <a:p>
+            <a:pPr indent="0" marL="0">
+              <a:buNone/>
+            </a:pPr>
+            <a:r>
+              <a:rPr lang="en-US" sz="1050" dirty="0">
+                <a:solidFill>
+                  <a:srgbClr val="B3AEA3"/>
+                </a:solidFill>
+                <a:latin typeface="Noto Sans KR" pitchFamily="34" charset="0"/>
+                <a:ea typeface="Noto Sans KR" pitchFamily="34" charset="-122"/>
+                <a:cs typeface="Noto Sans KR" pitchFamily="34" charset="-120"/>
+              </a:rPr>
+              <a:t>자체 작성 · ERC-7710 호환</a:t>
+            </a:r>
+            <a:endParaRPr lang="en-US" sz="1050" dirty="0"/>
+          </a:p>
+        </p:txBody>
+      </p:sp>
+      <p:sp>
+        <p:nvSpPr>
+          <p:cNvPr id="8" name="Text 6"/>
+          <p:cNvSpPr/>
+          <p:nvPr/>
+        </p:nvSpPr>
+        <p:spPr>
+          <a:xfrm>
+            <a:off x="6949440" y="1856232"/>
+            <a:ext cx="4434840" cy="365760"/>
+          </a:xfrm>
+          <a:prstGeom prst="rect">
+            <a:avLst/>
+          </a:prstGeom>
+          <a:noFill/>
+          <a:ln/>
+        </p:spPr>
+        <p:txBody>
+          <a:bodyPr wrap="square" lIns="0" tIns="0" rIns="0" bIns="0" rtlCol="0" anchor="ctr"/>
+          <a:lstStyle/>
+          <a:p>
+            <a:pPr indent="0" marL="0">
+              <a:buNone/>
+            </a:pPr>
+            <a:r>
+              <a:rPr lang="en-US" sz="1050" dirty="0">
                 <a:solidFill>
                   <a:srgbClr val="B3AEA3"/>
                 </a:solidFill>
@@ -9141,20 +9180,20 @@
               </a:rPr>
               <a:t>0xfd0fCCCcF8071852783b5133b3CC47461f33e6Cd</a:t>
             </a:r>
-            <a:endParaRPr lang="en-US" sz="1100" dirty="0"/>
-          </a:p>
-        </p:txBody>
-      </p:sp>
-      <p:sp>
-        <p:nvSpPr>
-          <p:cNvPr id="8" name="Text 6"/>
+            <a:endParaRPr lang="en-US" sz="1050" dirty="0"/>
+          </a:p>
+        </p:txBody>
+      </p:sp>
+      <p:sp>
+        <p:nvSpPr>
+          <p:cNvPr id="9" name="Text 7"/>
           <p:cNvSpPr/>
           <p:nvPr/>
         </p:nvSpPr>
         <p:spPr>
           <a:xfrm>
             <a:off x="822960" y="2340864"/>
-            <a:ext cx="5486400" cy="411480"/>
+            <a:ext cx="3200400" cy="411480"/>
           </a:xfrm>
           <a:prstGeom prst="rect">
             <a:avLst/>
@@ -9186,30 +9225,69 @@
       </p:sp>
       <p:sp>
         <p:nvSpPr>
-          <p:cNvPr id="9" name="Text 7"/>
-          <p:cNvSpPr/>
-          <p:nvPr/>
-        </p:nvSpPr>
-        <p:spPr>
-          <a:xfrm>
-            <a:off x="6400800" y="2368296"/>
-            <a:ext cx="4937760" cy="365760"/>
-          </a:xfrm>
-          <a:prstGeom prst="rect">
-            <a:avLst/>
-          </a:prstGeom>
-          <a:noFill/>
-          <a:ln/>
-        </p:spPr>
-        <p:txBody>
-          <a:bodyPr wrap="square" lIns="0" tIns="0" rIns="0" bIns="0" rtlCol="0" anchor="ctr"/>
-          <a:lstStyle/>
-          <a:p>
-            <a:pPr indent="0" marL="0">
-              <a:buNone/>
-            </a:pPr>
-            <a:r>
-              <a:rPr lang="en-US" sz="1100" dirty="0">
+          <p:cNvPr id="10" name="Text 8"/>
+          <p:cNvSpPr/>
+          <p:nvPr/>
+        </p:nvSpPr>
+        <p:spPr>
+          <a:xfrm>
+            <a:off x="3977640" y="2368296"/>
+            <a:ext cx="2880360" cy="365760"/>
+          </a:xfrm>
+          <a:prstGeom prst="rect">
+            <a:avLst/>
+          </a:prstGeom>
+          <a:noFill/>
+          <a:ln/>
+        </p:spPr>
+        <p:txBody>
+          <a:bodyPr wrap="square" lIns="0" tIns="0" rIns="0" bIns="0" rtlCol="0" anchor="ctr"/>
+          <a:lstStyle/>
+          <a:p>
+            <a:pPr indent="0" marL="0">
+              <a:buNone/>
+            </a:pPr>
+            <a:r>
+              <a:rPr lang="en-US" sz="1050" dirty="0">
+                <a:solidFill>
+                  <a:srgbClr val="B3AEA3"/>
+                </a:solidFill>
+                <a:latin typeface="Noto Sans KR" pitchFamily="34" charset="0"/>
+                <a:ea typeface="Noto Sans KR" pitchFamily="34" charset="-122"/>
+                <a:cs typeface="Noto Sans KR" pitchFamily="34" charset="-120"/>
+              </a:rPr>
+              <a:t>자체 설계 · EIP-712 소유자 결박</a:t>
+            </a:r>
+            <a:endParaRPr lang="en-US" sz="1050" dirty="0"/>
+          </a:p>
+        </p:txBody>
+      </p:sp>
+      <p:sp>
+        <p:nvSpPr>
+          <p:cNvPr id="11" name="Text 9"/>
+          <p:cNvSpPr/>
+          <p:nvPr/>
+        </p:nvSpPr>
+        <p:spPr>
+          <a:xfrm>
+            <a:off x="6949440" y="2368296"/>
+            <a:ext cx="4434840" cy="365760"/>
+          </a:xfrm>
+          <a:prstGeom prst="rect">
+            <a:avLst/>
+          </a:prstGeom>
+          <a:noFill/>
+          <a:ln/>
+        </p:spPr>
+        <p:txBody>
+          <a:bodyPr wrap="square" lIns="0" tIns="0" rIns="0" bIns="0" rtlCol="0" anchor="ctr"/>
+          <a:lstStyle/>
+          <a:p>
+            <a:pPr indent="0" marL="0">
+              <a:buNone/>
+            </a:pPr>
+            <a:r>
+              <a:rPr lang="en-US" sz="1050" dirty="0">
                 <a:solidFill>
                   <a:srgbClr val="B3AEA3"/>
                 </a:solidFill>
@@ -9219,20 +9297,20 @@
               </a:rPr>
               <a:t>0x157aF4D7b3f52685c817d5558b3468caD9b61299</a:t>
             </a:r>
-            <a:endParaRPr lang="en-US" sz="1100" dirty="0"/>
-          </a:p>
-        </p:txBody>
-      </p:sp>
-      <p:sp>
-        <p:nvSpPr>
-          <p:cNvPr id="10" name="Text 8"/>
+            <a:endParaRPr lang="en-US" sz="1050" dirty="0"/>
+          </a:p>
+        </p:txBody>
+      </p:sp>
+      <p:sp>
+        <p:nvSpPr>
+          <p:cNvPr id="12" name="Text 10"/>
           <p:cNvSpPr/>
           <p:nvPr/>
         </p:nvSpPr>
         <p:spPr>
           <a:xfrm>
             <a:off x="822960" y="2852928"/>
-            <a:ext cx="5486400" cy="411480"/>
+            <a:ext cx="3200400" cy="411480"/>
           </a:xfrm>
           <a:prstGeom prst="rect">
             <a:avLst/>
@@ -9256,7 +9334,7 @@
                 <a:ea typeface="Noto Sans KR" pitchFamily="34" charset="-122"/>
                 <a:cs typeface="Noto Sans KR" pitchFamily="34" charset="-120"/>
               </a:rPr>
-              <a:t>DojangVerifiedEnforcer  ★기여물</a:t>
+              <a:t>DojangVerifiedEnforcer</a:t>
             </a:r>
             <a:endParaRPr lang="en-US" sz="1250" dirty="0"/>
           </a:p>
@@ -9264,30 +9342,69 @@
       </p:sp>
       <p:sp>
         <p:nvSpPr>
-          <p:cNvPr id="11" name="Text 9"/>
-          <p:cNvSpPr/>
-          <p:nvPr/>
-        </p:nvSpPr>
-        <p:spPr>
-          <a:xfrm>
-            <a:off x="6400800" y="2880360"/>
-            <a:ext cx="4937760" cy="365760"/>
-          </a:xfrm>
-          <a:prstGeom prst="rect">
-            <a:avLst/>
-          </a:prstGeom>
-          <a:noFill/>
-          <a:ln/>
-        </p:spPr>
-        <p:txBody>
-          <a:bodyPr wrap="square" lIns="0" tIns="0" rIns="0" bIns="0" rtlCol="0" anchor="ctr"/>
-          <a:lstStyle/>
-          <a:p>
-            <a:pPr indent="0" marL="0">
-              <a:buNone/>
-            </a:pPr>
-            <a:r>
-              <a:rPr lang="en-US" sz="1100" dirty="0">
+          <p:cNvPr id="13" name="Text 11"/>
+          <p:cNvSpPr/>
+          <p:nvPr/>
+        </p:nvSpPr>
+        <p:spPr>
+          <a:xfrm>
+            <a:off x="3977640" y="2880360"/>
+            <a:ext cx="2880360" cy="365760"/>
+          </a:xfrm>
+          <a:prstGeom prst="rect">
+            <a:avLst/>
+          </a:prstGeom>
+          <a:noFill/>
+          <a:ln/>
+        </p:spPr>
+        <p:txBody>
+          <a:bodyPr wrap="square" lIns="0" tIns="0" rIns="0" bIns="0" rtlCol="0" anchor="ctr"/>
+          <a:lstStyle/>
+          <a:p>
+            <a:pPr indent="0" marL="0">
+              <a:buNone/>
+            </a:pPr>
+            <a:r>
+              <a:rPr lang="en-US" sz="1050" dirty="0">
+                <a:solidFill>
+                  <a:srgbClr val="D9AB77"/>
+                </a:solidFill>
+                <a:latin typeface="Noto Sans KR" pitchFamily="34" charset="0"/>
+                <a:ea typeface="Noto Sans KR" pitchFamily="34" charset="-122"/>
+                <a:cs typeface="Noto Sans KR" pitchFamily="34" charset="-120"/>
+              </a:rPr>
+              <a:t>★ 어디에도 없던 조건 — 기여물</a:t>
+            </a:r>
+            <a:endParaRPr lang="en-US" sz="1050" dirty="0"/>
+          </a:p>
+        </p:txBody>
+      </p:sp>
+      <p:sp>
+        <p:nvSpPr>
+          <p:cNvPr id="14" name="Text 12"/>
+          <p:cNvSpPr/>
+          <p:nvPr/>
+        </p:nvSpPr>
+        <p:spPr>
+          <a:xfrm>
+            <a:off x="6949440" y="2880360"/>
+            <a:ext cx="4434840" cy="365760"/>
+          </a:xfrm>
+          <a:prstGeom prst="rect">
+            <a:avLst/>
+          </a:prstGeom>
+          <a:noFill/>
+          <a:ln/>
+        </p:spPr>
+        <p:txBody>
+          <a:bodyPr wrap="square" lIns="0" tIns="0" rIns="0" bIns="0" rtlCol="0" anchor="ctr"/>
+          <a:lstStyle/>
+          <a:p>
+            <a:pPr indent="0" marL="0">
+              <a:buNone/>
+            </a:pPr>
+            <a:r>
+              <a:rPr lang="en-US" sz="1050" dirty="0">
                 <a:solidFill>
                   <a:srgbClr val="B3AEA3"/>
                 </a:solidFill>
@@ -9297,20 +9414,20 @@
               </a:rPr>
               <a:t>0xb2906a5079702B82C2973423d8cf91e8B41e6371</a:t>
             </a:r>
-            <a:endParaRPr lang="en-US" sz="1100" dirty="0"/>
-          </a:p>
-        </p:txBody>
-      </p:sp>
-      <p:sp>
-        <p:nvSpPr>
-          <p:cNvPr id="12" name="Text 10"/>
+            <a:endParaRPr lang="en-US" sz="1050" dirty="0"/>
+          </a:p>
+        </p:txBody>
+      </p:sp>
+      <p:sp>
+        <p:nvSpPr>
+          <p:cNvPr id="15" name="Text 13"/>
           <p:cNvSpPr/>
           <p:nvPr/>
         </p:nvSpPr>
         <p:spPr>
           <a:xfrm>
             <a:off x="822960" y="3364992"/>
-            <a:ext cx="5486400" cy="411480"/>
+            <a:ext cx="3200400" cy="411480"/>
           </a:xfrm>
           <a:prstGeom prst="rect">
             <a:avLst/>
@@ -9334,7 +9451,7 @@
                 <a:ea typeface="Noto Sans KR" pitchFamily="34" charset="-122"/>
                 <a:cs typeface="Noto Sans KR" pitchFamily="34" charset="-120"/>
               </a:rPr>
-              <a:t>AllowedPayeeEnforcer  ★오리지널</a:t>
+              <a:t>AllowedPayeeEnforcer</a:t>
             </a:r>
             <a:endParaRPr lang="en-US" sz="1250" dirty="0"/>
           </a:p>
@@ -9342,30 +9459,69 @@
       </p:sp>
       <p:sp>
         <p:nvSpPr>
-          <p:cNvPr id="13" name="Text 11"/>
-          <p:cNvSpPr/>
-          <p:nvPr/>
-        </p:nvSpPr>
-        <p:spPr>
-          <a:xfrm>
-            <a:off x="6400800" y="3392424"/>
-            <a:ext cx="4937760" cy="365760"/>
-          </a:xfrm>
-          <a:prstGeom prst="rect">
-            <a:avLst/>
-          </a:prstGeom>
-          <a:noFill/>
-          <a:ln/>
-        </p:spPr>
-        <p:txBody>
-          <a:bodyPr wrap="square" lIns="0" tIns="0" rIns="0" bIns="0" rtlCol="0" anchor="ctr"/>
-          <a:lstStyle/>
-          <a:p>
-            <a:pPr indent="0" marL="0">
-              <a:buNone/>
-            </a:pPr>
-            <a:r>
-              <a:rPr lang="en-US" sz="1100" dirty="0">
+          <p:cNvPr id="16" name="Text 14"/>
+          <p:cNvSpPr/>
+          <p:nvPr/>
+        </p:nvSpPr>
+        <p:spPr>
+          <a:xfrm>
+            <a:off x="3977640" y="3392424"/>
+            <a:ext cx="2880360" cy="365760"/>
+          </a:xfrm>
+          <a:prstGeom prst="rect">
+            <a:avLst/>
+          </a:prstGeom>
+          <a:noFill/>
+          <a:ln/>
+        </p:spPr>
+        <p:txBody>
+          <a:bodyPr wrap="square" lIns="0" tIns="0" rIns="0" bIns="0" rtlCol="0" anchor="ctr"/>
+          <a:lstStyle/>
+          <a:p>
+            <a:pPr indent="0" marL="0">
+              <a:buNone/>
+            </a:pPr>
+            <a:r>
+              <a:rPr lang="en-US" sz="1050" dirty="0">
+                <a:solidFill>
+                  <a:srgbClr val="D9AB77"/>
+                </a:solidFill>
+                <a:latin typeface="Noto Sans KR" pitchFamily="34" charset="0"/>
+                <a:ea typeface="Noto Sans KR" pitchFamily="34" charset="-122"/>
+                <a:cs typeface="Noto Sans KR" pitchFamily="34" charset="-120"/>
+              </a:rPr>
+              <a:t>★ 어디에도 없던 조건</a:t>
+            </a:r>
+            <a:endParaRPr lang="en-US" sz="1050" dirty="0"/>
+          </a:p>
+        </p:txBody>
+      </p:sp>
+      <p:sp>
+        <p:nvSpPr>
+          <p:cNvPr id="17" name="Text 15"/>
+          <p:cNvSpPr/>
+          <p:nvPr/>
+        </p:nvSpPr>
+        <p:spPr>
+          <a:xfrm>
+            <a:off x="6949440" y="3392424"/>
+            <a:ext cx="4434840" cy="365760"/>
+          </a:xfrm>
+          <a:prstGeom prst="rect">
+            <a:avLst/>
+          </a:prstGeom>
+          <a:noFill/>
+          <a:ln/>
+        </p:spPr>
+        <p:txBody>
+          <a:bodyPr wrap="square" lIns="0" tIns="0" rIns="0" bIns="0" rtlCol="0" anchor="ctr"/>
+          <a:lstStyle/>
+          <a:p>
+            <a:pPr indent="0" marL="0">
+              <a:buNone/>
+            </a:pPr>
+            <a:r>
+              <a:rPr lang="en-US" sz="1050" dirty="0">
                 <a:solidFill>
                   <a:srgbClr val="B3AEA3"/>
                 </a:solidFill>
@@ -9375,20 +9531,20 @@
               </a:rPr>
               <a:t>0x7eF0f193B721B1749d890F1e231C8074670f1bD1</a:t>
             </a:r>
-            <a:endParaRPr lang="en-US" sz="1100" dirty="0"/>
-          </a:p>
-        </p:txBody>
-      </p:sp>
-      <p:sp>
-        <p:nvSpPr>
-          <p:cNvPr id="14" name="Text 12"/>
+            <a:endParaRPr lang="en-US" sz="1050" dirty="0"/>
+          </a:p>
+        </p:txBody>
+      </p:sp>
+      <p:sp>
+        <p:nvSpPr>
+          <p:cNvPr id="18" name="Text 16"/>
           <p:cNvSpPr/>
           <p:nvPr/>
         </p:nvSpPr>
         <p:spPr>
           <a:xfrm>
             <a:off x="822960" y="3877056"/>
-            <a:ext cx="5486400" cy="411480"/>
+            <a:ext cx="3200400" cy="411480"/>
           </a:xfrm>
           <a:prstGeom prst="rect">
             <a:avLst/>
@@ -9412,7 +9568,7 @@
                 <a:ea typeface="Noto Sans KR" pitchFamily="34" charset="-122"/>
                 <a:cs typeface="Noto Sans KR" pitchFamily="34" charset="-120"/>
               </a:rPr>
-              <a:t>ERC20PeriodTransferEnforcer  (MetaMask 감사본 vendored)</a:t>
+              <a:t>ERC20PeriodTransferEnforcer</a:t>
             </a:r>
             <a:endParaRPr lang="en-US" sz="1250" dirty="0"/>
           </a:p>
@@ -9420,30 +9576,69 @@
       </p:sp>
       <p:sp>
         <p:nvSpPr>
-          <p:cNvPr id="15" name="Text 13"/>
-          <p:cNvSpPr/>
-          <p:nvPr/>
-        </p:nvSpPr>
-        <p:spPr>
-          <a:xfrm>
-            <a:off x="6400800" y="3904488"/>
-            <a:ext cx="4937760" cy="365760"/>
-          </a:xfrm>
-          <a:prstGeom prst="rect">
-            <a:avLst/>
-          </a:prstGeom>
-          <a:noFill/>
-          <a:ln/>
-        </p:spPr>
-        <p:txBody>
-          <a:bodyPr wrap="square" lIns="0" tIns="0" rIns="0" bIns="0" rtlCol="0" anchor="ctr"/>
-          <a:lstStyle/>
-          <a:p>
-            <a:pPr indent="0" marL="0">
-              <a:buNone/>
-            </a:pPr>
-            <a:r>
-              <a:rPr lang="en-US" sz="1100" dirty="0">
+          <p:cNvPr id="19" name="Text 17"/>
+          <p:cNvSpPr/>
+          <p:nvPr/>
+        </p:nvSpPr>
+        <p:spPr>
+          <a:xfrm>
+            <a:off x="3977640" y="3904488"/>
+            <a:ext cx="2880360" cy="365760"/>
+          </a:xfrm>
+          <a:prstGeom prst="rect">
+            <a:avLst/>
+          </a:prstGeom>
+          <a:noFill/>
+          <a:ln/>
+        </p:spPr>
+        <p:txBody>
+          <a:bodyPr wrap="square" lIns="0" tIns="0" rIns="0" bIns="0" rtlCol="0" anchor="ctr"/>
+          <a:lstStyle/>
+          <a:p>
+            <a:pPr indent="0" marL="0">
+              <a:buNone/>
+            </a:pPr>
+            <a:r>
+              <a:rPr lang="en-US" sz="1050" dirty="0">
+                <a:solidFill>
+                  <a:srgbClr val="817C73"/>
+                </a:solidFill>
+                <a:latin typeface="Noto Sans KR" pitchFamily="34" charset="0"/>
+                <a:ea typeface="Noto Sans KR" pitchFamily="34" charset="-122"/>
+                <a:cs typeface="Noto Sans KR" pitchFamily="34" charset="-120"/>
+              </a:rPr>
+              <a:t>MetaMask 감사본 무수정 vendored</a:t>
+            </a:r>
+            <a:endParaRPr lang="en-US" sz="1050" dirty="0"/>
+          </a:p>
+        </p:txBody>
+      </p:sp>
+      <p:sp>
+        <p:nvSpPr>
+          <p:cNvPr id="20" name="Text 18"/>
+          <p:cNvSpPr/>
+          <p:nvPr/>
+        </p:nvSpPr>
+        <p:spPr>
+          <a:xfrm>
+            <a:off x="6949440" y="3904488"/>
+            <a:ext cx="4434840" cy="365760"/>
+          </a:xfrm>
+          <a:prstGeom prst="rect">
+            <a:avLst/>
+          </a:prstGeom>
+          <a:noFill/>
+          <a:ln/>
+        </p:spPr>
+        <p:txBody>
+          <a:bodyPr wrap="square" lIns="0" tIns="0" rIns="0" bIns="0" rtlCol="0" anchor="ctr"/>
+          <a:lstStyle/>
+          <a:p>
+            <a:pPr indent="0" marL="0">
+              <a:buNone/>
+            </a:pPr>
+            <a:r>
+              <a:rPr lang="en-US" sz="1050" dirty="0">
                 <a:solidFill>
                   <a:srgbClr val="B3AEA3"/>
                 </a:solidFill>
@@ -9453,20 +9648,20 @@
               </a:rPr>
               <a:t>0xE33ba891fa502A075D3E422258723eF4cB6AC892</a:t>
             </a:r>
-            <a:endParaRPr lang="en-US" sz="1100" dirty="0"/>
-          </a:p>
-        </p:txBody>
-      </p:sp>
-      <p:sp>
-        <p:nvSpPr>
-          <p:cNvPr id="16" name="Text 14"/>
+            <a:endParaRPr lang="en-US" sz="1050" dirty="0"/>
+          </a:p>
+        </p:txBody>
+      </p:sp>
+      <p:sp>
+        <p:nvSpPr>
+          <p:cNvPr id="21" name="Text 19"/>
           <p:cNvSpPr/>
           <p:nvPr/>
         </p:nvSpPr>
         <p:spPr>
           <a:xfrm>
             <a:off x="822960" y="4389120"/>
-            <a:ext cx="5486400" cy="411480"/>
+            <a:ext cx="3200400" cy="411480"/>
           </a:xfrm>
           <a:prstGeom prst="rect">
             <a:avLst/>
@@ -9490,7 +9685,7 @@
                 <a:ea typeface="Noto Sans KR" pitchFamily="34" charset="-122"/>
                 <a:cs typeface="Noto Sans KR" pitchFamily="34" charset="-120"/>
               </a:rPr>
-              <a:t>TimestampEnforcer  (MetaMask 감사본 vendored)</a:t>
+              <a:t>TimestampEnforcer</a:t>
             </a:r>
             <a:endParaRPr lang="en-US" sz="1250" dirty="0"/>
           </a:p>
@@ -9498,30 +9693,69 @@
       </p:sp>
       <p:sp>
         <p:nvSpPr>
-          <p:cNvPr id="17" name="Text 15"/>
-          <p:cNvSpPr/>
-          <p:nvPr/>
-        </p:nvSpPr>
-        <p:spPr>
-          <a:xfrm>
-            <a:off x="6400800" y="4416552"/>
-            <a:ext cx="4937760" cy="365760"/>
-          </a:xfrm>
-          <a:prstGeom prst="rect">
-            <a:avLst/>
-          </a:prstGeom>
-          <a:noFill/>
-          <a:ln/>
-        </p:spPr>
-        <p:txBody>
-          <a:bodyPr wrap="square" lIns="0" tIns="0" rIns="0" bIns="0" rtlCol="0" anchor="ctr"/>
-          <a:lstStyle/>
-          <a:p>
-            <a:pPr indent="0" marL="0">
-              <a:buNone/>
-            </a:pPr>
-            <a:r>
-              <a:rPr lang="en-US" sz="1100" dirty="0">
+          <p:cNvPr id="22" name="Text 20"/>
+          <p:cNvSpPr/>
+          <p:nvPr/>
+        </p:nvSpPr>
+        <p:spPr>
+          <a:xfrm>
+            <a:off x="3977640" y="4416552"/>
+            <a:ext cx="2880360" cy="365760"/>
+          </a:xfrm>
+          <a:prstGeom prst="rect">
+            <a:avLst/>
+          </a:prstGeom>
+          <a:noFill/>
+          <a:ln/>
+        </p:spPr>
+        <p:txBody>
+          <a:bodyPr wrap="square" lIns="0" tIns="0" rIns="0" bIns="0" rtlCol="0" anchor="ctr"/>
+          <a:lstStyle/>
+          <a:p>
+            <a:pPr indent="0" marL="0">
+              <a:buNone/>
+            </a:pPr>
+            <a:r>
+              <a:rPr lang="en-US" sz="1050" dirty="0">
+                <a:solidFill>
+                  <a:srgbClr val="817C73"/>
+                </a:solidFill>
+                <a:latin typeface="Noto Sans KR" pitchFamily="34" charset="0"/>
+                <a:ea typeface="Noto Sans KR" pitchFamily="34" charset="-122"/>
+                <a:cs typeface="Noto Sans KR" pitchFamily="34" charset="-120"/>
+              </a:rPr>
+              <a:t>MetaMask 감사본 무수정 vendored</a:t>
+            </a:r>
+            <a:endParaRPr lang="en-US" sz="1050" dirty="0"/>
+          </a:p>
+        </p:txBody>
+      </p:sp>
+      <p:sp>
+        <p:nvSpPr>
+          <p:cNvPr id="23" name="Text 21"/>
+          <p:cNvSpPr/>
+          <p:nvPr/>
+        </p:nvSpPr>
+        <p:spPr>
+          <a:xfrm>
+            <a:off x="6949440" y="4416552"/>
+            <a:ext cx="4434840" cy="365760"/>
+          </a:xfrm>
+          <a:prstGeom prst="rect">
+            <a:avLst/>
+          </a:prstGeom>
+          <a:noFill/>
+          <a:ln/>
+        </p:spPr>
+        <p:txBody>
+          <a:bodyPr wrap="square" lIns="0" tIns="0" rIns="0" bIns="0" rtlCol="0" anchor="ctr"/>
+          <a:lstStyle/>
+          <a:p>
+            <a:pPr indent="0" marL="0">
+              <a:buNone/>
+            </a:pPr>
+            <a:r>
+              <a:rPr lang="en-US" sz="1050" dirty="0">
                 <a:solidFill>
                   <a:srgbClr val="B3AEA3"/>
                 </a:solidFill>
@@ -9531,20 +9765,20 @@
               </a:rPr>
               <a:t>0x2911cB5D4aeBCa3e42FAaa5488b6e04df3C9cc02</a:t>
             </a:r>
-            <a:endParaRPr lang="en-US" sz="1100" dirty="0"/>
-          </a:p>
-        </p:txBody>
-      </p:sp>
-      <p:sp>
-        <p:nvSpPr>
-          <p:cNvPr id="18" name="Text 16"/>
+            <a:endParaRPr lang="en-US" sz="1050" dirty="0"/>
+          </a:p>
+        </p:txBody>
+      </p:sp>
+      <p:sp>
+        <p:nvSpPr>
+          <p:cNvPr id="24" name="Text 22"/>
           <p:cNvSpPr/>
           <p:nvPr/>
         </p:nvSpPr>
         <p:spPr>
           <a:xfrm>
             <a:off x="822960" y="4901184"/>
-            <a:ext cx="5486400" cy="411480"/>
+            <a:ext cx="3200400" cy="411480"/>
           </a:xfrm>
           <a:prstGeom prst="rect">
             <a:avLst/>
@@ -9568,7 +9802,7 @@
                 <a:ea typeface="Noto Sans KR" pitchFamily="34" charset="-122"/>
                 <a:cs typeface="Noto Sans KR" pitchFamily="34" charset="-120"/>
               </a:rPr>
-              <a:t>VerifiedCodeEnforcer  ★오리지널</a:t>
+              <a:t>VerifiedCodeEnforcer</a:t>
             </a:r>
             <a:endParaRPr lang="en-US" sz="1250" dirty="0"/>
           </a:p>
@@ -9576,30 +9810,69 @@
       </p:sp>
       <p:sp>
         <p:nvSpPr>
-          <p:cNvPr id="19" name="Text 17"/>
-          <p:cNvSpPr/>
-          <p:nvPr/>
-        </p:nvSpPr>
-        <p:spPr>
-          <a:xfrm>
-            <a:off x="6400800" y="4928616"/>
-            <a:ext cx="4937760" cy="365760"/>
-          </a:xfrm>
-          <a:prstGeom prst="rect">
-            <a:avLst/>
-          </a:prstGeom>
-          <a:noFill/>
-          <a:ln/>
-        </p:spPr>
-        <p:txBody>
-          <a:bodyPr wrap="square" lIns="0" tIns="0" rIns="0" bIns="0" rtlCol="0" anchor="ctr"/>
-          <a:lstStyle/>
-          <a:p>
-            <a:pPr indent="0" marL="0">
-              <a:buNone/>
-            </a:pPr>
-            <a:r>
-              <a:rPr lang="en-US" sz="1100" dirty="0">
+          <p:cNvPr id="25" name="Text 23"/>
+          <p:cNvSpPr/>
+          <p:nvPr/>
+        </p:nvSpPr>
+        <p:spPr>
+          <a:xfrm>
+            <a:off x="3977640" y="4928616"/>
+            <a:ext cx="2880360" cy="365760"/>
+          </a:xfrm>
+          <a:prstGeom prst="rect">
+            <a:avLst/>
+          </a:prstGeom>
+          <a:noFill/>
+          <a:ln/>
+        </p:spPr>
+        <p:txBody>
+          <a:bodyPr wrap="square" lIns="0" tIns="0" rIns="0" bIns="0" rtlCol="0" anchor="ctr"/>
+          <a:lstStyle/>
+          <a:p>
+            <a:pPr indent="0" marL="0">
+              <a:buNone/>
+            </a:pPr>
+            <a:r>
+              <a:rPr lang="en-US" sz="1050" dirty="0">
+                <a:solidFill>
+                  <a:srgbClr val="D9AB77"/>
+                </a:solidFill>
+                <a:latin typeface="Noto Sans KR" pitchFamily="34" charset="0"/>
+                <a:ea typeface="Noto Sans KR" pitchFamily="34" charset="-122"/>
+                <a:cs typeface="Noto Sans KR" pitchFamily="34" charset="-120"/>
+              </a:rPr>
+              <a:t>★ 어디에도 없던 조건</a:t>
+            </a:r>
+            <a:endParaRPr lang="en-US" sz="1050" dirty="0"/>
+          </a:p>
+        </p:txBody>
+      </p:sp>
+      <p:sp>
+        <p:nvSpPr>
+          <p:cNvPr id="26" name="Text 24"/>
+          <p:cNvSpPr/>
+          <p:nvPr/>
+        </p:nvSpPr>
+        <p:spPr>
+          <a:xfrm>
+            <a:off x="6949440" y="4928616"/>
+            <a:ext cx="4434840" cy="365760"/>
+          </a:xfrm>
+          <a:prstGeom prst="rect">
+            <a:avLst/>
+          </a:prstGeom>
+          <a:noFill/>
+          <a:ln/>
+        </p:spPr>
+        <p:txBody>
+          <a:bodyPr wrap="square" lIns="0" tIns="0" rIns="0" bIns="0" rtlCol="0" anchor="ctr"/>
+          <a:lstStyle/>
+          <a:p>
+            <a:pPr indent="0" marL="0">
+              <a:buNone/>
+            </a:pPr>
+            <a:r>
+              <a:rPr lang="en-US" sz="1050" dirty="0">
                 <a:solidFill>
                   <a:srgbClr val="B3AEA3"/>
                 </a:solidFill>
@@ -9609,20 +9882,20 @@
               </a:rPr>
               <a:t>0x1C640E0A70b1E18B120bB20952e81Df8F6b8650e</a:t>
             </a:r>
-            <a:endParaRPr lang="en-US" sz="1100" dirty="0"/>
-          </a:p>
-        </p:txBody>
-      </p:sp>
-      <p:sp>
-        <p:nvSpPr>
-          <p:cNvPr id="20" name="Text 18"/>
+            <a:endParaRPr lang="en-US" sz="1050" dirty="0"/>
+          </a:p>
+        </p:txBody>
+      </p:sp>
+      <p:sp>
+        <p:nvSpPr>
+          <p:cNvPr id="27" name="Text 25"/>
           <p:cNvSpPr/>
           <p:nvPr/>
         </p:nvSpPr>
         <p:spPr>
           <a:xfrm>
             <a:off x="822960" y="5413248"/>
-            <a:ext cx="5486400" cy="411480"/>
+            <a:ext cx="3200400" cy="411480"/>
           </a:xfrm>
           <a:prstGeom prst="rect">
             <a:avLst/>
@@ -9646,7 +9919,7 @@
                 <a:ea typeface="Noto Sans KR" pitchFamily="34" charset="-122"/>
                 <a:cs typeface="Noto Sans KR" pitchFamily="34" charset="-120"/>
               </a:rPr>
-              <a:t>MockKRW  (자산 불가지론의 placeholder)</a:t>
+              <a:t>MockKRW</a:t>
             </a:r>
             <a:endParaRPr lang="en-US" sz="1250" dirty="0"/>
           </a:p>
@@ -9654,30 +9927,69 @@
       </p:sp>
       <p:sp>
         <p:nvSpPr>
-          <p:cNvPr id="21" name="Text 19"/>
-          <p:cNvSpPr/>
-          <p:nvPr/>
-        </p:nvSpPr>
-        <p:spPr>
-          <a:xfrm>
-            <a:off x="6400800" y="5440680"/>
-            <a:ext cx="4937760" cy="365760"/>
-          </a:xfrm>
-          <a:prstGeom prst="rect">
-            <a:avLst/>
-          </a:prstGeom>
-          <a:noFill/>
-          <a:ln/>
-        </p:spPr>
-        <p:txBody>
-          <a:bodyPr wrap="square" lIns="0" tIns="0" rIns="0" bIns="0" rtlCol="0" anchor="ctr"/>
-          <a:lstStyle/>
-          <a:p>
-            <a:pPr indent="0" marL="0">
-              <a:buNone/>
-            </a:pPr>
-            <a:r>
-              <a:rPr lang="en-US" sz="1100" dirty="0">
+          <p:cNvPr id="28" name="Text 26"/>
+          <p:cNvSpPr/>
+          <p:nvPr/>
+        </p:nvSpPr>
+        <p:spPr>
+          <a:xfrm>
+            <a:off x="3977640" y="5440680"/>
+            <a:ext cx="2880360" cy="365760"/>
+          </a:xfrm>
+          <a:prstGeom prst="rect">
+            <a:avLst/>
+          </a:prstGeom>
+          <a:noFill/>
+          <a:ln/>
+        </p:spPr>
+        <p:txBody>
+          <a:bodyPr wrap="square" lIns="0" tIns="0" rIns="0" bIns="0" rtlCol="0" anchor="ctr"/>
+          <a:lstStyle/>
+          <a:p>
+            <a:pPr indent="0" marL="0">
+              <a:buNone/>
+            </a:pPr>
+            <a:r>
+              <a:rPr lang="en-US" sz="1050" dirty="0">
+                <a:solidFill>
+                  <a:srgbClr val="B3AEA3"/>
+                </a:solidFill>
+                <a:latin typeface="Noto Sans KR" pitchFamily="34" charset="0"/>
+                <a:ea typeface="Noto Sans KR" pitchFamily="34" charset="-122"/>
+                <a:cs typeface="Noto Sans KR" pitchFamily="34" charset="-120"/>
+              </a:rPr>
+              <a:t>자체 작성 · 자산 불가지론의 placeholder</a:t>
+            </a:r>
+            <a:endParaRPr lang="en-US" sz="1050" dirty="0"/>
+          </a:p>
+        </p:txBody>
+      </p:sp>
+      <p:sp>
+        <p:nvSpPr>
+          <p:cNvPr id="29" name="Text 27"/>
+          <p:cNvSpPr/>
+          <p:nvPr/>
+        </p:nvSpPr>
+        <p:spPr>
+          <a:xfrm>
+            <a:off x="6949440" y="5440680"/>
+            <a:ext cx="4434840" cy="365760"/>
+          </a:xfrm>
+          <a:prstGeom prst="rect">
+            <a:avLst/>
+          </a:prstGeom>
+          <a:noFill/>
+          <a:ln/>
+        </p:spPr>
+        <p:txBody>
+          <a:bodyPr wrap="square" lIns="0" tIns="0" rIns="0" bIns="0" rtlCol="0" anchor="ctr"/>
+          <a:lstStyle/>
+          <a:p>
+            <a:pPr indent="0" marL="0">
+              <a:buNone/>
+            </a:pPr>
+            <a:r>
+              <a:rPr lang="en-US" sz="1050" dirty="0">
                 <a:solidFill>
                   <a:srgbClr val="B3AEA3"/>
                 </a:solidFill>
@@ -9687,46 +9999,49 @@
               </a:rPr>
               <a:t>0x8bd74916E3427B4eF8Bed3D2F49241056E5e4F2B</a:t>
             </a:r>
+            <a:endParaRPr lang="en-US" sz="1050" dirty="0"/>
+          </a:p>
+        </p:txBody>
+      </p:sp>
+      <p:sp>
+        <p:nvSpPr>
+          <p:cNvPr id="30" name="Text 28"/>
+          <p:cNvSpPr/>
+          <p:nvPr/>
+        </p:nvSpPr>
+        <p:spPr>
+          <a:xfrm>
+            <a:off x="822960" y="5870448"/>
+            <a:ext cx="10543032" cy="640080"/>
+          </a:xfrm>
+          <a:prstGeom prst="rect">
+            <a:avLst/>
+          </a:prstGeom>
+          <a:noFill/>
+          <a:ln/>
+        </p:spPr>
+        <p:txBody>
+          <a:bodyPr wrap="square" lIns="0" tIns="0" rIns="0" bIns="0" rtlCol="0" anchor="ctr"/>
+          <a:lstStyle/>
+          <a:p>
+            <a:pPr indent="0" marL="0">
+              <a:lnSpc>
+                <a:spcPct val="130000"/>
+              </a:lnSpc>
+              <a:buNone/>
+            </a:pPr>
+            <a:r>
+              <a:rPr lang="en-US" sz="1100" dirty="0">
+                <a:solidFill>
+                  <a:srgbClr val="817C73"/>
+                </a:solidFill>
+                <a:latin typeface="Noto Sans KR" pitchFamily="34" charset="0"/>
+                <a:ea typeface="Noto Sans KR" pitchFamily="34" charset="-122"/>
+                <a:cs typeface="Noto Sans KR" pitchFamily="34" charset="-120"/>
+              </a:rPr>
+              <a:t>vendored 2건 외 여섯은 전부 자체 작성이다. ★는 저작 표시가 아니라 “배포된 어떤 프레임워크에도 없는 조건”이라는 주장이며 — 감사본이 무수정으로 도는 것 자체가 호환성 증명이다. 검증 상태는 pnpm check-verified 가 Blockscout API의 is_verified 로 매번 다시 확인한다.</a:t>
+            </a:r>
             <a:endParaRPr lang="en-US" sz="1100" dirty="0"/>
-          </a:p>
-        </p:txBody>
-      </p:sp>
-      <p:sp>
-        <p:nvSpPr>
-          <p:cNvPr id="22" name="Text 20"/>
-          <p:cNvSpPr/>
-          <p:nvPr/>
-        </p:nvSpPr>
-        <p:spPr>
-          <a:xfrm>
-            <a:off x="822960" y="6035040"/>
-            <a:ext cx="10543032" cy="320040"/>
-          </a:xfrm>
-          <a:prstGeom prst="rect">
-            <a:avLst/>
-          </a:prstGeom>
-          <a:noFill/>
-          <a:ln/>
-        </p:spPr>
-        <p:txBody>
-          <a:bodyPr wrap="square" lIns="0" tIns="0" rIns="0" bIns="0" rtlCol="0" anchor="ctr"/>
-          <a:lstStyle/>
-          <a:p>
-            <a:pPr indent="0" marL="0">
-              <a:buNone/>
-            </a:pPr>
-            <a:r>
-              <a:rPr lang="en-US" sz="1150" dirty="0">
-                <a:solidFill>
-                  <a:srgbClr val="817C73"/>
-                </a:solidFill>
-                <a:latin typeface="Noto Sans KR" pitchFamily="34" charset="0"/>
-                <a:ea typeface="Noto Sans KR" pitchFamily="34" charset="-122"/>
-                <a:cs typeface="Noto Sans KR" pitchFamily="34" charset="-120"/>
-              </a:rPr>
-              <a:t>검증 상태는 pnpm check-verified 가 Blockscout API에서 매번 다시 확인한다 — 화면이 아니라 API의 is_verified 를 읽는다.</a:t>
-            </a:r>
-            <a:endParaRPr lang="en-US" sz="1150" dirty="0"/>
           </a:p>
         </p:txBody>
       </p:sp>

</xml_diff>